<commit_message>
Fix: yangi Stil_gamma2 shablon o'rnatildi; duplicate_slide_with_rels ishlatiladi — background va rasmlar to'g'ri nusxalanadi
</commit_message>
<xml_diff>
--- a/templates/shablonlar/gamma2.pptx
+++ b/templates/shablonlar/gamma2.pptx
@@ -1140,7 +1140,7 @@
           <a:p>
             <a:fld id="{710AE426-CBD1-49BA-A1DA-945CCEE2ED80}" type="datetimeFigureOut">
               <a:rPr lang="en-US" smtClean="0"/>
-              <a:t>8/1/2026</a:t>
+              <a:t>8/6/2026</a:t>
             </a:fld>
             <a:endParaRPr lang="en-US"/>
           </a:p>
@@ -1484,7 +1484,7 @@
           <a:p>
             <a:fld id="{710AE426-CBD1-49BA-A1DA-945CCEE2ED80}" type="datetimeFigureOut">
               <a:rPr lang="en-US" smtClean="0"/>
-              <a:t>8/1/2026</a:t>
+              <a:t>8/6/2026</a:t>
             </a:fld>
             <a:endParaRPr lang="en-US"/>
           </a:p>
@@ -1764,7 +1764,7 @@
           <a:p>
             <a:fld id="{710AE426-CBD1-49BA-A1DA-945CCEE2ED80}" type="datetimeFigureOut">
               <a:rPr lang="en-US" smtClean="0"/>
-              <a:t>8/1/2026</a:t>
+              <a:t>8/6/2026</a:t>
             </a:fld>
             <a:endParaRPr lang="en-US"/>
           </a:p>
@@ -1997,7 +1997,7 @@
           <a:p>
             <a:fld id="{710AE426-CBD1-49BA-A1DA-945CCEE2ED80}" type="datetimeFigureOut">
               <a:rPr lang="en-US" smtClean="0"/>
-              <a:t>8/1/2026</a:t>
+              <a:t>8/6/2026</a:t>
             </a:fld>
             <a:endParaRPr lang="en-US"/>
           </a:p>
@@ -2286,7 +2286,7 @@
           <a:p>
             <a:fld id="{710AE426-CBD1-49BA-A1DA-945CCEE2ED80}" type="datetimeFigureOut">
               <a:rPr lang="en-US" smtClean="0"/>
-              <a:t>8/1/2026</a:t>
+              <a:t>8/6/2026</a:t>
             </a:fld>
             <a:endParaRPr lang="en-US"/>
           </a:p>
@@ -2575,7 +2575,7 @@
           <a:p>
             <a:fld id="{710AE426-CBD1-49BA-A1DA-945CCEE2ED80}" type="datetimeFigureOut">
               <a:rPr lang="en-US" smtClean="0"/>
-              <a:t>8/1/2026</a:t>
+              <a:t>8/6/2026</a:t>
             </a:fld>
             <a:endParaRPr lang="en-US"/>
           </a:p>
@@ -2982,7 +2982,7 @@
           <a:p>
             <a:fld id="{710AE426-CBD1-49BA-A1DA-945CCEE2ED80}" type="datetimeFigureOut">
               <a:rPr lang="en-US" smtClean="0"/>
-              <a:t>8/1/2026</a:t>
+              <a:t>8/6/2026</a:t>
             </a:fld>
             <a:endParaRPr lang="en-US"/>
           </a:p>
@@ -3275,7 +3275,7 @@
           <a:p>
             <a:fld id="{710AE426-CBD1-49BA-A1DA-945CCEE2ED80}" type="datetimeFigureOut">
               <a:rPr lang="en-US" smtClean="0"/>
-              <a:t>8/1/2026</a:t>
+              <a:t>8/6/2026</a:t>
             </a:fld>
             <a:endParaRPr lang="en-US"/>
           </a:p>
@@ -3549,7 +3549,7 @@
           <a:p>
             <a:fld id="{710AE426-CBD1-49BA-A1DA-945CCEE2ED80}" type="datetimeFigureOut">
               <a:rPr lang="en-US" smtClean="0"/>
-              <a:t>8/1/2026</a:t>
+              <a:t>8/6/2026</a:t>
             </a:fld>
             <a:endParaRPr lang="en-US"/>
           </a:p>
@@ -3819,7 +3819,7 @@
           <a:p>
             <a:fld id="{710AE426-CBD1-49BA-A1DA-945CCEE2ED80}" type="datetimeFigureOut">
               <a:rPr lang="en-US" smtClean="0"/>
-              <a:t>8/1/2026</a:t>
+              <a:t>8/6/2026</a:t>
             </a:fld>
             <a:endParaRPr lang="en-US"/>
           </a:p>
@@ -4051,7 +4051,7 @@
           <a:p>
             <a:fld id="{710AE426-CBD1-49BA-A1DA-945CCEE2ED80}" type="datetimeFigureOut">
               <a:rPr lang="en-US" smtClean="0"/>
-              <a:t>8/1/2026</a:t>
+              <a:t>8/6/2026</a:t>
             </a:fld>
             <a:endParaRPr lang="en-US"/>
           </a:p>
@@ -4272,7 +4272,7 @@
           <a:p>
             <a:fld id="{710AE426-CBD1-49BA-A1DA-945CCEE2ED80}" type="datetimeFigureOut">
               <a:rPr lang="en-US" smtClean="0"/>
-              <a:t>8/1/2026</a:t>
+              <a:t>8/6/2026</a:t>
             </a:fld>
             <a:endParaRPr lang="en-US"/>
           </a:p>
@@ -4525,7 +4525,7 @@
           <a:p>
             <a:fld id="{710AE426-CBD1-49BA-A1DA-945CCEE2ED80}" type="datetimeFigureOut">
               <a:rPr lang="en-US" smtClean="0"/>
-              <a:t>8/1/2026</a:t>
+              <a:t>8/6/2026</a:t>
             </a:fld>
             <a:endParaRPr lang="en-US"/>
           </a:p>
@@ -4737,7 +4737,7 @@
           <a:p>
             <a:fld id="{710AE426-CBD1-49BA-A1DA-945CCEE2ED80}" type="datetimeFigureOut">
               <a:rPr lang="en-US" smtClean="0"/>
-              <a:t>8/1/2026</a:t>
+              <a:t>8/6/2026</a:t>
             </a:fld>
             <a:endParaRPr lang="en-US"/>
           </a:p>
@@ -5018,7 +5018,7 @@
           <a:p>
             <a:fld id="{710AE426-CBD1-49BA-A1DA-945CCEE2ED80}" type="datetimeFigureOut">
               <a:rPr lang="en-US" smtClean="0"/>
-              <a:t>8/1/2026</a:t>
+              <a:t>8/6/2026</a:t>
             </a:fld>
             <a:endParaRPr lang="en-US"/>
           </a:p>
@@ -5451,7 +5451,7 @@
           <a:p>
             <a:fld id="{710AE426-CBD1-49BA-A1DA-945CCEE2ED80}" type="datetimeFigureOut">
               <a:rPr lang="en-US" smtClean="0"/>
-              <a:t>8/1/2026</a:t>
+              <a:t>8/6/2026</a:t>
             </a:fld>
             <a:endParaRPr lang="en-US"/>
           </a:p>
@@ -5606,7 +5606,7 @@
           <a:p>
             <a:fld id="{710AE426-CBD1-49BA-A1DA-945CCEE2ED80}" type="datetimeFigureOut">
               <a:rPr lang="en-US" smtClean="0"/>
-              <a:t>8/1/2026</a:t>
+              <a:t>8/6/2026</a:t>
             </a:fld>
             <a:endParaRPr lang="en-US"/>
           </a:p>
@@ -5720,7 +5720,7 @@
           <a:p>
             <a:fld id="{710AE426-CBD1-49BA-A1DA-945CCEE2ED80}" type="datetimeFigureOut">
               <a:rPr lang="en-US" smtClean="0"/>
-              <a:t>8/1/2026</a:t>
+              <a:t>8/6/2026</a:t>
             </a:fld>
             <a:endParaRPr lang="en-US"/>
           </a:p>
@@ -5963,7 +5963,7 @@
           <a:p>
             <a:fld id="{710AE426-CBD1-49BA-A1DA-945CCEE2ED80}" type="datetimeFigureOut">
               <a:rPr lang="en-US" smtClean="0"/>
-              <a:t>8/1/2026</a:t>
+              <a:t>8/6/2026</a:t>
             </a:fld>
             <a:endParaRPr lang="en-US"/>
           </a:p>
@@ -6208,7 +6208,7 @@
           <a:p>
             <a:fld id="{710AE426-CBD1-49BA-A1DA-945CCEE2ED80}" type="datetimeFigureOut">
               <a:rPr lang="en-US" smtClean="0"/>
-              <a:t>8/1/2026</a:t>
+              <a:t>8/6/2026</a:t>
             </a:fld>
             <a:endParaRPr lang="en-US"/>
           </a:p>
@@ -6549,7 +6549,7 @@
           <a:p>
             <a:fld id="{710AE426-CBD1-49BA-A1DA-945CCEE2ED80}" type="datetimeFigureOut">
               <a:rPr lang="en-US" smtClean="0"/>
-              <a:t>8/1/2026</a:t>
+              <a:t>8/6/2026</a:t>
             </a:fld>
             <a:endParaRPr lang="en-US"/>
           </a:p>
@@ -6777,7 +6777,7 @@
           <a:p>
             <a:fld id="{710AE426-CBD1-49BA-A1DA-945CCEE2ED80}" type="datetimeFigureOut">
               <a:rPr lang="en-US" smtClean="0"/>
-              <a:t>8/1/2026</a:t>
+              <a:t>8/6/2026</a:t>
             </a:fld>
             <a:endParaRPr lang="en-US"/>
           </a:p>
@@ -6962,7 +6962,7 @@
           <a:p>
             <a:fld id="{710AE426-CBD1-49BA-A1DA-945CCEE2ED80}" type="datetimeFigureOut">
               <a:rPr lang="en-US" smtClean="0"/>
-              <a:t>8/1/2026</a:t>
+              <a:t>8/6/2026</a:t>
             </a:fld>
             <a:endParaRPr lang="en-US"/>
           </a:p>
@@ -7227,7 +7227,7 @@
           <a:p>
             <a:fld id="{710AE426-CBD1-49BA-A1DA-945CCEE2ED80}" type="datetimeFigureOut">
               <a:rPr lang="en-US" smtClean="0"/>
-              <a:t>8/1/2026</a:t>
+              <a:t>8/6/2026</a:t>
             </a:fld>
             <a:endParaRPr lang="en-US"/>
           </a:p>
@@ -7576,7 +7576,7 @@
           <a:p>
             <a:fld id="{710AE426-CBD1-49BA-A1DA-945CCEE2ED80}" type="datetimeFigureOut">
               <a:rPr lang="en-US" smtClean="0"/>
-              <a:t>8/1/2026</a:t>
+              <a:t>8/6/2026</a:t>
             </a:fld>
             <a:endParaRPr lang="en-US"/>
           </a:p>
@@ -7799,7 +7799,7 @@
           <a:p>
             <a:fld id="{710AE426-CBD1-49BA-A1DA-945CCEE2ED80}" type="datetimeFigureOut">
               <a:rPr lang="en-US" smtClean="0"/>
-              <a:t>8/1/2026</a:t>
+              <a:t>8/6/2026</a:t>
             </a:fld>
             <a:endParaRPr lang="en-US"/>
           </a:p>
@@ -8017,7 +8017,7 @@
           <a:p>
             <a:fld id="{710AE426-CBD1-49BA-A1DA-945CCEE2ED80}" type="datetimeFigureOut">
               <a:rPr lang="en-US" smtClean="0"/>
-              <a:t>8/1/2026</a:t>
+              <a:t>8/6/2026</a:t>
             </a:fld>
             <a:endParaRPr lang="en-US"/>
           </a:p>
@@ -8275,7 +8275,7 @@
           <a:p>
             <a:fld id="{710AE426-CBD1-49BA-A1DA-945CCEE2ED80}" type="datetimeFigureOut">
               <a:rPr lang="en-US" smtClean="0"/>
-              <a:t>8/1/2026</a:t>
+              <a:t>8/6/2026</a:t>
             </a:fld>
             <a:endParaRPr lang="en-US"/>
           </a:p>
@@ -9252,9 +9252,15 @@
   <p:cSld name="Slide 4">
     <p:bg>
       <p:bgPr>
-        <a:solidFill>
-          <a:srgbClr val="202733"/>
-        </a:solidFill>
+        <a:blipFill dpi="0" rotWithShape="1">
+          <a:blip r:embed="rId3">
+            <a:lum/>
+          </a:blip>
+          <a:srcRect/>
+          <a:stretch>
+            <a:fillRect/>
+          </a:stretch>
+        </a:blipFill>
         <a:effectLst/>
       </p:bgPr>
     </p:bg>
@@ -9281,7 +9287,7 @@
           <p:nvPr/>
         </p:nvPicPr>
         <p:blipFill>
-          <a:blip r:embed="rId3"/>
+          <a:blip r:embed="rId4"/>
           <a:stretch>
             <a:fillRect/>
           </a:stretch>
@@ -9342,35 +9348,6 @@
       </p:sp>
       <p:sp>
         <p:nvSpPr>
-          <p:cNvPr id="4" name="Shape 1"/>
-          <p:cNvSpPr/>
-          <p:nvPr/>
-        </p:nvSpPr>
-        <p:spPr>
-          <a:xfrm>
-            <a:off x="496119" y="1779687"/>
-            <a:ext cx="2290465" cy="1270471"/>
-          </a:xfrm>
-          <a:prstGeom prst="roundRect">
-            <a:avLst>
-              <a:gd name="adj" fmla="val 1674"/>
-            </a:avLst>
-          </a:prstGeom>
-          <a:solidFill>
-            <a:srgbClr val="3F4652"/>
-          </a:solidFill>
-          <a:ln/>
-        </p:spPr>
-        <p:txBody>
-          <a:bodyPr/>
-          <a:lstStyle/>
-          <a:p>
-            <a:endParaRPr lang="ru-RU"/>
-          </a:p>
-        </p:txBody>
-      </p:sp>
-      <p:sp>
-        <p:nvSpPr>
           <p:cNvPr id="5" name="Text 2"/>
           <p:cNvSpPr/>
           <p:nvPr/>
@@ -9457,35 +9434,6 @@
       </p:sp>
       <p:sp>
         <p:nvSpPr>
-          <p:cNvPr id="7" name="Shape 4"/>
-          <p:cNvSpPr/>
-          <p:nvPr/>
-        </p:nvSpPr>
-        <p:spPr>
-          <a:xfrm>
-            <a:off x="2928342" y="1779687"/>
-            <a:ext cx="2290539" cy="1270471"/>
-          </a:xfrm>
-          <a:prstGeom prst="roundRect">
-            <a:avLst>
-              <a:gd name="adj" fmla="val 1674"/>
-            </a:avLst>
-          </a:prstGeom>
-          <a:solidFill>
-            <a:srgbClr val="3F4652"/>
-          </a:solidFill>
-          <a:ln/>
-        </p:spPr>
-        <p:txBody>
-          <a:bodyPr/>
-          <a:lstStyle/>
-          <a:p>
-            <a:endParaRPr lang="ru-RU"/>
-          </a:p>
-        </p:txBody>
-      </p:sp>
-      <p:sp>
-        <p:nvSpPr>
           <p:cNvPr id="8" name="Text 5"/>
           <p:cNvSpPr/>
           <p:nvPr/>
@@ -9572,35 +9520,6 @@
       </p:sp>
       <p:sp>
         <p:nvSpPr>
-          <p:cNvPr id="10" name="Shape 7"/>
-          <p:cNvSpPr/>
-          <p:nvPr/>
-        </p:nvSpPr>
-        <p:spPr>
-          <a:xfrm>
-            <a:off x="496119" y="3191917"/>
-            <a:ext cx="2290465" cy="1270471"/>
-          </a:xfrm>
-          <a:prstGeom prst="roundRect">
-            <a:avLst>
-              <a:gd name="adj" fmla="val 1674"/>
-            </a:avLst>
-          </a:prstGeom>
-          <a:solidFill>
-            <a:srgbClr val="3F4652"/>
-          </a:solidFill>
-          <a:ln/>
-        </p:spPr>
-        <p:txBody>
-          <a:bodyPr/>
-          <a:lstStyle/>
-          <a:p>
-            <a:endParaRPr lang="ru-RU"/>
-          </a:p>
-        </p:txBody>
-      </p:sp>
-      <p:sp>
-        <p:nvSpPr>
           <p:cNvPr id="11" name="Text 8"/>
           <p:cNvSpPr/>
           <p:nvPr/>
@@ -9682,35 +9601,6 @@
               <a:t>Axborot makoni barcha sohalar uchun umumiy bo'lgan umumiy axborot muhitidir.</a:t>
             </a:r>
             <a:endParaRPr lang="en-US" sz="1100" dirty="0"/>
-          </a:p>
-        </p:txBody>
-      </p:sp>
-      <p:sp>
-        <p:nvSpPr>
-          <p:cNvPr id="13" name="Shape 10"/>
-          <p:cNvSpPr/>
-          <p:nvPr/>
-        </p:nvSpPr>
-        <p:spPr>
-          <a:xfrm>
-            <a:off x="2928342" y="3191917"/>
-            <a:ext cx="2290539" cy="1270471"/>
-          </a:xfrm>
-          <a:prstGeom prst="roundRect">
-            <a:avLst>
-              <a:gd name="adj" fmla="val 1674"/>
-            </a:avLst>
-          </a:prstGeom>
-          <a:solidFill>
-            <a:srgbClr val="3F4652"/>
-          </a:solidFill>
-          <a:ln/>
-        </p:spPr>
-        <p:txBody>
-          <a:bodyPr/>
-          <a:lstStyle/>
-          <a:p>
-            <a:endParaRPr lang="ru-RU"/>
           </a:p>
         </p:txBody>
       </p:sp>
@@ -9813,9 +9703,15 @@
   <p:cSld name="Slide 5">
     <p:bg>
       <p:bgPr>
-        <a:solidFill>
-          <a:srgbClr val="202733"/>
-        </a:solidFill>
+        <a:blipFill dpi="0" rotWithShape="1">
+          <a:blip r:embed="rId3">
+            <a:lum/>
+          </a:blip>
+          <a:srcRect/>
+          <a:stretch>
+            <a:fillRect/>
+          </a:stretch>
+        </a:blipFill>
         <a:effectLst/>
       </p:bgPr>
     </p:bg>
@@ -9842,7 +9738,7 @@
           <p:nvPr/>
         </p:nvPicPr>
         <p:blipFill>
-          <a:blip r:embed="rId3"/>
+          <a:blip r:embed="rId4"/>
           <a:stretch>
             <a:fillRect/>
           </a:stretch>
@@ -9903,135 +9799,6 @@
       </p:sp>
       <p:sp>
         <p:nvSpPr>
-          <p:cNvPr id="4" name="Shape 1"/>
-          <p:cNvSpPr/>
-          <p:nvPr/>
-        </p:nvSpPr>
-        <p:spPr>
-          <a:xfrm>
-            <a:off x="653058" y="1649239"/>
-            <a:ext cx="19050" cy="2923208"/>
-          </a:xfrm>
-          <a:prstGeom prst="roundRect">
-            <a:avLst>
-              <a:gd name="adj" fmla="val 50000"/>
-            </a:avLst>
-          </a:prstGeom>
-          <a:solidFill>
-            <a:srgbClr val="585F6B"/>
-          </a:solidFill>
-          <a:ln/>
-        </p:spPr>
-        <p:txBody>
-          <a:bodyPr/>
-          <a:lstStyle/>
-          <a:p>
-            <a:endParaRPr lang="ru-RU"/>
-          </a:p>
-        </p:txBody>
-      </p:sp>
-      <p:sp>
-        <p:nvSpPr>
-          <p:cNvPr id="5" name="Shape 2"/>
-          <p:cNvSpPr/>
-          <p:nvPr/>
-        </p:nvSpPr>
-        <p:spPr>
-          <a:xfrm>
-            <a:off x="790984" y="1796653"/>
-            <a:ext cx="418654" cy="19050"/>
-          </a:xfrm>
-          <a:prstGeom prst="roundRect">
-            <a:avLst>
-              <a:gd name="adj" fmla="val 50000"/>
-            </a:avLst>
-          </a:prstGeom>
-          <a:solidFill>
-            <a:srgbClr val="585F6B"/>
-          </a:solidFill>
-          <a:ln/>
-        </p:spPr>
-        <p:txBody>
-          <a:bodyPr/>
-          <a:lstStyle/>
-          <a:p>
-            <a:endParaRPr lang="ru-RU"/>
-          </a:p>
-        </p:txBody>
-      </p:sp>
-      <p:sp>
-        <p:nvSpPr>
-          <p:cNvPr id="6" name="Shape 3"/>
-          <p:cNvSpPr/>
-          <p:nvPr/>
-        </p:nvSpPr>
-        <p:spPr>
-          <a:xfrm>
-            <a:off x="496081" y="1649239"/>
-            <a:ext cx="313953" cy="313953"/>
-          </a:xfrm>
-          <a:prstGeom prst="roundRect">
-            <a:avLst>
-              <a:gd name="adj" fmla="val 6668"/>
-            </a:avLst>
-          </a:prstGeom>
-          <a:solidFill>
-            <a:srgbClr val="3F4652"/>
-          </a:solidFill>
-          <a:ln/>
-        </p:spPr>
-        <p:txBody>
-          <a:bodyPr/>
-          <a:lstStyle/>
-          <a:p>
-            <a:endParaRPr lang="ru-RU"/>
-          </a:p>
-        </p:txBody>
-      </p:sp>
-      <p:sp>
-        <p:nvSpPr>
-          <p:cNvPr id="7" name="Text 4"/>
-          <p:cNvSpPr/>
-          <p:nvPr/>
-        </p:nvSpPr>
-        <p:spPr>
-          <a:xfrm>
-            <a:off x="548357" y="1675358"/>
-            <a:ext cx="209327" cy="261640"/>
-          </a:xfrm>
-          <a:prstGeom prst="rect">
-            <a:avLst/>
-          </a:prstGeom>
-          <a:noFill/>
-          <a:ln/>
-        </p:spPr>
-        <p:txBody>
-          <a:bodyPr wrap="none" lIns="0" tIns="0" rIns="0" bIns="0" rtlCol="0" anchor="ctr"/>
-          <a:lstStyle/>
-          <a:p>
-            <a:pPr marL="0" indent="0" algn="ctr">
-              <a:lnSpc>
-                <a:spcPct val="100000"/>
-              </a:lnSpc>
-              <a:buNone/>
-            </a:pPr>
-            <a:r>
-              <a:rPr lang="en-US" sz="1600" dirty="0">
-                <a:solidFill>
-                  <a:srgbClr val="D6E5EF"/>
-                </a:solidFill>
-                <a:latin typeface="Roboto Slab" pitchFamily="34" charset="0"/>
-                <a:ea typeface="Roboto Slab" pitchFamily="34" charset="-122"/>
-                <a:cs typeface="Roboto Slab" pitchFamily="34" charset="-120"/>
-              </a:rPr>
-              <a:t>1</a:t>
-            </a:r>
-            <a:endParaRPr lang="en-US" sz="1600" dirty="0"/>
-          </a:p>
-        </p:txBody>
-      </p:sp>
-      <p:sp>
-        <p:nvSpPr>
           <p:cNvPr id="8" name="Text 5"/>
           <p:cNvSpPr/>
           <p:nvPr/>
@@ -10118,106 +9885,6 @@
       </p:sp>
       <p:sp>
         <p:nvSpPr>
-          <p:cNvPr id="10" name="Shape 7"/>
-          <p:cNvSpPr/>
-          <p:nvPr/>
-        </p:nvSpPr>
-        <p:spPr>
-          <a:xfrm>
-            <a:off x="790984" y="2862635"/>
-            <a:ext cx="418654" cy="19050"/>
-          </a:xfrm>
-          <a:prstGeom prst="roundRect">
-            <a:avLst>
-              <a:gd name="adj" fmla="val 50000"/>
-            </a:avLst>
-          </a:prstGeom>
-          <a:solidFill>
-            <a:srgbClr val="585F6B"/>
-          </a:solidFill>
-          <a:ln/>
-        </p:spPr>
-        <p:txBody>
-          <a:bodyPr/>
-          <a:lstStyle/>
-          <a:p>
-            <a:endParaRPr lang="ru-RU"/>
-          </a:p>
-        </p:txBody>
-      </p:sp>
-      <p:sp>
-        <p:nvSpPr>
-          <p:cNvPr id="11" name="Shape 8"/>
-          <p:cNvSpPr/>
-          <p:nvPr/>
-        </p:nvSpPr>
-        <p:spPr>
-          <a:xfrm>
-            <a:off x="496081" y="2715220"/>
-            <a:ext cx="313953" cy="313953"/>
-          </a:xfrm>
-          <a:prstGeom prst="roundRect">
-            <a:avLst>
-              <a:gd name="adj" fmla="val 6668"/>
-            </a:avLst>
-          </a:prstGeom>
-          <a:solidFill>
-            <a:srgbClr val="3F4652"/>
-          </a:solidFill>
-          <a:ln/>
-        </p:spPr>
-        <p:txBody>
-          <a:bodyPr/>
-          <a:lstStyle/>
-          <a:p>
-            <a:endParaRPr lang="ru-RU"/>
-          </a:p>
-        </p:txBody>
-      </p:sp>
-      <p:sp>
-        <p:nvSpPr>
-          <p:cNvPr id="12" name="Text 9"/>
-          <p:cNvSpPr/>
-          <p:nvPr/>
-        </p:nvSpPr>
-        <p:spPr>
-          <a:xfrm>
-            <a:off x="548357" y="2741340"/>
-            <a:ext cx="209327" cy="261640"/>
-          </a:xfrm>
-          <a:prstGeom prst="rect">
-            <a:avLst/>
-          </a:prstGeom>
-          <a:noFill/>
-          <a:ln/>
-        </p:spPr>
-        <p:txBody>
-          <a:bodyPr wrap="none" lIns="0" tIns="0" rIns="0" bIns="0" rtlCol="0" anchor="ctr"/>
-          <a:lstStyle/>
-          <a:p>
-            <a:pPr marL="0" indent="0" algn="ctr">
-              <a:lnSpc>
-                <a:spcPct val="100000"/>
-              </a:lnSpc>
-              <a:buNone/>
-            </a:pPr>
-            <a:r>
-              <a:rPr lang="en-US" sz="1600" dirty="0">
-                <a:solidFill>
-                  <a:srgbClr val="D6E5EF"/>
-                </a:solidFill>
-                <a:latin typeface="Roboto Slab" pitchFamily="34" charset="0"/>
-                <a:ea typeface="Roboto Slab" pitchFamily="34" charset="-122"/>
-                <a:cs typeface="Roboto Slab" pitchFamily="34" charset="-120"/>
-              </a:rPr>
-              <a:t>2</a:t>
-            </a:r>
-            <a:endParaRPr lang="en-US" sz="1600" dirty="0"/>
-          </a:p>
-        </p:txBody>
-      </p:sp>
-      <p:sp>
-        <p:nvSpPr>
           <p:cNvPr id="13" name="Text 10"/>
           <p:cNvSpPr/>
           <p:nvPr/>
@@ -10299,106 +9966,6 @@
               <a:t>Ma'lumotlarni uzatish va aloqa o'rnatish uchun Internet va boshqa tarmoqlar.</a:t>
             </a:r>
             <a:endParaRPr lang="en-US" sz="1050" dirty="0"/>
-          </a:p>
-        </p:txBody>
-      </p:sp>
-      <p:sp>
-        <p:nvSpPr>
-          <p:cNvPr id="15" name="Shape 12"/>
-          <p:cNvSpPr/>
-          <p:nvPr/>
-        </p:nvSpPr>
-        <p:spPr>
-          <a:xfrm>
-            <a:off x="790984" y="3928616"/>
-            <a:ext cx="418654" cy="19050"/>
-          </a:xfrm>
-          <a:prstGeom prst="roundRect">
-            <a:avLst>
-              <a:gd name="adj" fmla="val 50000"/>
-            </a:avLst>
-          </a:prstGeom>
-          <a:solidFill>
-            <a:srgbClr val="585F6B"/>
-          </a:solidFill>
-          <a:ln/>
-        </p:spPr>
-        <p:txBody>
-          <a:bodyPr/>
-          <a:lstStyle/>
-          <a:p>
-            <a:endParaRPr lang="ru-RU"/>
-          </a:p>
-        </p:txBody>
-      </p:sp>
-      <p:sp>
-        <p:nvSpPr>
-          <p:cNvPr id="16" name="Shape 13"/>
-          <p:cNvSpPr/>
-          <p:nvPr/>
-        </p:nvSpPr>
-        <p:spPr>
-          <a:xfrm>
-            <a:off x="496081" y="3781202"/>
-            <a:ext cx="313953" cy="313953"/>
-          </a:xfrm>
-          <a:prstGeom prst="roundRect">
-            <a:avLst>
-              <a:gd name="adj" fmla="val 6668"/>
-            </a:avLst>
-          </a:prstGeom>
-          <a:solidFill>
-            <a:srgbClr val="3F4652"/>
-          </a:solidFill>
-          <a:ln/>
-        </p:spPr>
-        <p:txBody>
-          <a:bodyPr/>
-          <a:lstStyle/>
-          <a:p>
-            <a:endParaRPr lang="ru-RU"/>
-          </a:p>
-        </p:txBody>
-      </p:sp>
-      <p:sp>
-        <p:nvSpPr>
-          <p:cNvPr id="17" name="Text 14"/>
-          <p:cNvSpPr/>
-          <p:nvPr/>
-        </p:nvSpPr>
-        <p:spPr>
-          <a:xfrm>
-            <a:off x="548357" y="3807321"/>
-            <a:ext cx="209327" cy="261640"/>
-          </a:xfrm>
-          <a:prstGeom prst="rect">
-            <a:avLst/>
-          </a:prstGeom>
-          <a:noFill/>
-          <a:ln/>
-        </p:spPr>
-        <p:txBody>
-          <a:bodyPr wrap="none" lIns="0" tIns="0" rIns="0" bIns="0" rtlCol="0" anchor="ctr"/>
-          <a:lstStyle/>
-          <a:p>
-            <a:pPr marL="0" indent="0" algn="ctr">
-              <a:lnSpc>
-                <a:spcPct val="100000"/>
-              </a:lnSpc>
-              <a:buNone/>
-            </a:pPr>
-            <a:r>
-              <a:rPr lang="en-US" sz="1600" dirty="0">
-                <a:solidFill>
-                  <a:srgbClr val="D6E5EF"/>
-                </a:solidFill>
-                <a:latin typeface="Roboto Slab" pitchFamily="34" charset="0"/>
-                <a:ea typeface="Roboto Slab" pitchFamily="34" charset="-122"/>
-                <a:cs typeface="Roboto Slab" pitchFamily="34" charset="-120"/>
-              </a:rPr>
-              <a:t>3</a:t>
-            </a:r>
-            <a:endParaRPr lang="en-US" sz="1600" dirty="0"/>
           </a:p>
         </p:txBody>
       </p:sp>
@@ -10501,9 +10068,15 @@
   <p:cSld name="Slide 6">
     <p:bg>
       <p:bgPr>
-        <a:solidFill>
-          <a:srgbClr val="202733"/>
-        </a:solidFill>
+        <a:blipFill dpi="0" rotWithShape="1">
+          <a:blip r:embed="rId3">
+            <a:lum/>
+          </a:blip>
+          <a:srcRect/>
+          <a:stretch>
+            <a:fillRect/>
+          </a:stretch>
+        </a:blipFill>
         <a:effectLst/>
       </p:bgPr>
     </p:bg>
@@ -10530,7 +10103,7 @@
           <p:nvPr/>
         </p:nvPicPr>
         <p:blipFill>
-          <a:blip r:embed="rId3"/>
+          <a:blip r:embed="rId4"/>
           <a:stretch>
             <a:fillRect/>
           </a:stretch>
@@ -10589,36 +10162,6 @@
           </a:p>
         </p:txBody>
       </p:sp>
-      <p:pic>
-        <p:nvPicPr>
-          <p:cNvPr id="4" name="Image 1" descr="preencoded.png"/>
-          <p:cNvPicPr>
-            <a:picLocks noChangeAspect="1"/>
-          </p:cNvPicPr>
-          <p:nvPr/>
-        </p:nvPicPr>
-        <p:blipFill>
-          <a:blip>
-            <a:extLst>
-              <a:ext uri="{96DAC541-7B7A-43D3-8B79-37D633B846F1}">
-                <asvg:svgBlip xmlns:asvg="http://schemas.microsoft.com/office/drawing/2016/SVG/main" r:embed="rId4"/>
-              </a:ext>
-            </a:extLst>
-          </a:blip>
-          <a:stretch>
-            <a:fillRect/>
-          </a:stretch>
-        </p:blipFill>
-        <p:spPr>
-          <a:xfrm>
-            <a:off x="496119" y="1394445"/>
-            <a:ext cx="310083" cy="310083"/>
-          </a:xfrm>
-          <a:prstGeom prst="rect">
-            <a:avLst/>
-          </a:prstGeom>
-        </p:spPr>
-      </p:pic>
       <p:sp>
         <p:nvSpPr>
           <p:cNvPr id="5" name="Text 1"/>
@@ -10703,36 +10246,6 @@
           </a:p>
         </p:txBody>
       </p:sp>
-      <p:pic>
-        <p:nvPicPr>
-          <p:cNvPr id="7" name="Image 2" descr="preencoded.png"/>
-          <p:cNvPicPr>
-            <a:picLocks noChangeAspect="1"/>
-          </p:cNvPicPr>
-          <p:nvPr/>
-        </p:nvPicPr>
-        <p:blipFill>
-          <a:blip>
-            <a:extLst>
-              <a:ext uri="{96DAC541-7B7A-43D3-8B79-37D633B846F1}">
-                <asvg:svgBlip xmlns:asvg="http://schemas.microsoft.com/office/drawing/2016/SVG/main" r:embed="rId5"/>
-              </a:ext>
-            </a:extLst>
-          </a:blip>
-          <a:stretch>
-            <a:fillRect/>
-          </a:stretch>
-        </p:blipFill>
-        <p:spPr>
-          <a:xfrm>
-            <a:off x="496119" y="2502247"/>
-            <a:ext cx="310083" cy="310083"/>
-          </a:xfrm>
-          <a:prstGeom prst="rect">
-            <a:avLst/>
-          </a:prstGeom>
-        </p:spPr>
-      </p:pic>
       <p:sp>
         <p:nvSpPr>
           <p:cNvPr id="8" name="Text 3"/>
@@ -10817,36 +10330,6 @@
           </a:p>
         </p:txBody>
       </p:sp>
-      <p:pic>
-        <p:nvPicPr>
-          <p:cNvPr id="10" name="Image 3" descr="preencoded.png"/>
-          <p:cNvPicPr>
-            <a:picLocks noChangeAspect="1"/>
-          </p:cNvPicPr>
-          <p:nvPr/>
-        </p:nvPicPr>
-        <p:blipFill>
-          <a:blip>
-            <a:extLst>
-              <a:ext uri="{96DAC541-7B7A-43D3-8B79-37D633B846F1}">
-                <asvg:svgBlip xmlns:asvg="http://schemas.microsoft.com/office/drawing/2016/SVG/main" r:embed="rId6"/>
-              </a:ext>
-            </a:extLst>
-          </a:blip>
-          <a:stretch>
-            <a:fillRect/>
-          </a:stretch>
-        </p:blipFill>
-        <p:spPr>
-          <a:xfrm>
-            <a:off x="496119" y="3610049"/>
-            <a:ext cx="310083" cy="310083"/>
-          </a:xfrm>
-          <a:prstGeom prst="rect">
-            <a:avLst/>
-          </a:prstGeom>
-        </p:spPr>
-      </p:pic>
       <p:sp>
         <p:nvSpPr>
           <p:cNvPr id="11" name="Text 5"/>
@@ -10946,9 +10429,15 @@
   <p:cSld name="Slide 7">
     <p:bg>
       <p:bgPr>
-        <a:solidFill>
-          <a:srgbClr val="202733"/>
-        </a:solidFill>
+        <a:blipFill dpi="0" rotWithShape="1">
+          <a:blip r:embed="rId3">
+            <a:lum/>
+          </a:blip>
+          <a:srcRect/>
+          <a:stretch>
+            <a:fillRect/>
+          </a:stretch>
+        </a:blipFill>
         <a:effectLst/>
       </p:bgPr>
     </p:bg>
@@ -10975,7 +10464,7 @@
           <p:nvPr/>
         </p:nvPicPr>
         <p:blipFill>
-          <a:blip r:embed="rId3"/>
+          <a:blip r:embed="rId4"/>
           <a:stretch>
             <a:fillRect/>
           </a:stretch>
@@ -11034,30 +10523,6 @@
           </a:p>
         </p:txBody>
       </p:sp>
-      <p:pic>
-        <p:nvPicPr>
-          <p:cNvPr id="4" name="Image 1" descr="preencoded.png"/>
-          <p:cNvPicPr>
-            <a:picLocks noChangeAspect="1"/>
-          </p:cNvPicPr>
-          <p:nvPr/>
-        </p:nvPicPr>
-        <p:blipFill>
-          <a:blip r:embed="rId4"/>
-          <a:stretch>
-            <a:fillRect/>
-          </a:stretch>
-        </p:blipFill>
-        <p:spPr>
-          <a:xfrm>
-            <a:off x="496119" y="1555552"/>
-            <a:ext cx="708794" cy="1043657"/>
-          </a:xfrm>
-          <a:prstGeom prst="rect">
-            <a:avLst/>
-          </a:prstGeom>
-        </p:spPr>
-      </p:pic>
       <p:sp>
         <p:nvSpPr>
           <p:cNvPr id="5" name="Text 1"/>
@@ -11144,30 +10609,6 @@
           </a:p>
         </p:txBody>
       </p:sp>
-      <p:pic>
-        <p:nvPicPr>
-          <p:cNvPr id="7" name="Image 2" descr="preencoded.png"/>
-          <p:cNvPicPr>
-            <a:picLocks noChangeAspect="1"/>
-          </p:cNvPicPr>
-          <p:nvPr/>
-        </p:nvPicPr>
-        <p:blipFill>
-          <a:blip r:embed="rId5"/>
-          <a:stretch>
-            <a:fillRect/>
-          </a:stretch>
-        </p:blipFill>
-        <p:spPr>
-          <a:xfrm>
-            <a:off x="496119" y="2599209"/>
-            <a:ext cx="708794" cy="1043657"/>
-          </a:xfrm>
-          <a:prstGeom prst="rect">
-            <a:avLst/>
-          </a:prstGeom>
-        </p:spPr>
-      </p:pic>
       <p:sp>
         <p:nvSpPr>
           <p:cNvPr id="8" name="Text 3"/>
@@ -11254,30 +10695,6 @@
           </a:p>
         </p:txBody>
       </p:sp>
-      <p:pic>
-        <p:nvPicPr>
-          <p:cNvPr id="10" name="Image 3" descr="preencoded.png"/>
-          <p:cNvPicPr>
-            <a:picLocks noChangeAspect="1"/>
-          </p:cNvPicPr>
-          <p:nvPr/>
-        </p:nvPicPr>
-        <p:blipFill>
-          <a:blip r:embed="rId6"/>
-          <a:stretch>
-            <a:fillRect/>
-          </a:stretch>
-        </p:blipFill>
-        <p:spPr>
-          <a:xfrm>
-            <a:off x="496119" y="3642866"/>
-            <a:ext cx="708794" cy="1043657"/>
-          </a:xfrm>
-          <a:prstGeom prst="rect">
-            <a:avLst/>
-          </a:prstGeom>
-        </p:spPr>
-      </p:pic>
       <p:sp>
         <p:nvSpPr>
           <p:cNvPr id="11" name="Text 5"/>
@@ -11377,9 +10794,15 @@
   <p:cSld name="Slide 9">
     <p:bg>
       <p:bgPr>
-        <a:solidFill>
-          <a:srgbClr val="202733"/>
-        </a:solidFill>
+        <a:blipFill dpi="0" rotWithShape="1">
+          <a:blip r:embed="rId3">
+            <a:lum/>
+          </a:blip>
+          <a:srcRect/>
+          <a:stretch>
+            <a:fillRect/>
+          </a:stretch>
+        </a:blipFill>
         <a:effectLst/>
       </p:bgPr>
     </p:bg>
@@ -11406,7 +10829,7 @@
           <p:nvPr/>
         </p:nvPicPr>
         <p:blipFill>
-          <a:blip r:embed="rId3"/>
+          <a:blip r:embed="rId4"/>
           <a:stretch>
             <a:fillRect/>
           </a:stretch>
@@ -11467,35 +10890,6 @@
       </p:sp>
       <p:sp>
         <p:nvSpPr>
-          <p:cNvPr id="4" name="Shape 1"/>
-          <p:cNvSpPr/>
-          <p:nvPr/>
-        </p:nvSpPr>
-        <p:spPr>
-          <a:xfrm>
-            <a:off x="3925119" y="2003822"/>
-            <a:ext cx="2290465" cy="1491928"/>
-          </a:xfrm>
-          <a:prstGeom prst="roundRect">
-            <a:avLst>
-              <a:gd name="adj" fmla="val 1425"/>
-            </a:avLst>
-          </a:prstGeom>
-          <a:solidFill>
-            <a:srgbClr val="3F4652"/>
-          </a:solidFill>
-          <a:ln/>
-        </p:spPr>
-        <p:txBody>
-          <a:bodyPr/>
-          <a:lstStyle/>
-          <a:p>
-            <a:endParaRPr lang="ru-RU"/>
-          </a:p>
-        </p:txBody>
-      </p:sp>
-      <p:sp>
-        <p:nvSpPr>
           <p:cNvPr id="5" name="Text 2"/>
           <p:cNvSpPr/>
           <p:nvPr/>
@@ -11582,35 +10976,6 @@
       </p:sp>
       <p:sp>
         <p:nvSpPr>
-          <p:cNvPr id="7" name="Shape 4"/>
-          <p:cNvSpPr/>
-          <p:nvPr/>
-        </p:nvSpPr>
-        <p:spPr>
-          <a:xfrm>
-            <a:off x="6357342" y="2003822"/>
-            <a:ext cx="2290539" cy="1491928"/>
-          </a:xfrm>
-          <a:prstGeom prst="roundRect">
-            <a:avLst>
-              <a:gd name="adj" fmla="val 1425"/>
-            </a:avLst>
-          </a:prstGeom>
-          <a:solidFill>
-            <a:srgbClr val="3F4652"/>
-          </a:solidFill>
-          <a:ln/>
-        </p:spPr>
-        <p:txBody>
-          <a:bodyPr/>
-          <a:lstStyle/>
-          <a:p>
-            <a:endParaRPr lang="ru-RU"/>
-          </a:p>
-        </p:txBody>
-      </p:sp>
-      <p:sp>
-        <p:nvSpPr>
           <p:cNvPr id="8" name="Text 5"/>
           <p:cNvSpPr/>
           <p:nvPr/>
@@ -11694,35 +11059,6 @@
               <a:t>Axborot resurslaridan samarali foydalanish va ularni qayta ishlash.</a:t>
             </a:r>
             <a:endParaRPr lang="en-US" sz="1100" dirty="0"/>
-          </a:p>
-        </p:txBody>
-      </p:sp>
-      <p:sp>
-        <p:nvSpPr>
-          <p:cNvPr id="10" name="Shape 7"/>
-          <p:cNvSpPr/>
-          <p:nvPr/>
-        </p:nvSpPr>
-        <p:spPr>
-          <a:xfrm>
-            <a:off x="3925119" y="3637508"/>
-            <a:ext cx="4722763" cy="1043657"/>
-          </a:xfrm>
-          <a:prstGeom prst="roundRect">
-            <a:avLst>
-              <a:gd name="adj" fmla="val 2038"/>
-            </a:avLst>
-          </a:prstGeom>
-          <a:solidFill>
-            <a:srgbClr val="3F4652"/>
-          </a:solidFill>
-          <a:ln/>
-        </p:spPr>
-        <p:txBody>
-          <a:bodyPr/>
-          <a:lstStyle/>
-          <a:p>
-            <a:endParaRPr lang="ru-RU"/>
           </a:p>
         </p:txBody>
       </p:sp>

</xml_diff>